<commit_message>
feat: Tạo slide Bài 1 Tin học cho 9 lớp (Tiền TH + Lớp 1-8)
- Tạo script generate_slides_bai1_tin_hoc.py: đọc KHBD tự động, tạo slide .pptx
- 9 file slide mới: Tiền TH (10 slides), Lớp 1-5 (10 slides), Lớp 6-8 (8 slides)
- Cập nhật nội quy Tin học & Robotics trong slide Tiết 00 (16 file .pptx)
- Trích xuất trang SGK Bài 1 cho Lớp 3-8 (extract_sgk_bai1_pages.py)
- 9 bộ Color Palette riêng cho mỗi lớp
- Hỗ trợ 2 format KHBD: TH (bảng GV|HS) và THCS (4 hoạt động + bảng 3 cột)
</commit_message>
<xml_diff>
--- a/KHBD_Robotics/Lớp_1/Tiết_00/Slide_Robotics_Lop_1_Tiet00_Dinh_huong.pptx
+++ b/KHBD_Robotics/Lớp_1/Tiết_00/Slide_Robotics_Lop_1_Tiet00_Dinh_huong.pptx
@@ -14,6 +14,8 @@
     <p:sldId id="262" r:id="rId12"/>
     <p:sldId id="263" r:id="rId13"/>
     <p:sldId id="264" r:id="rId14"/>
+    <p:sldId id="265" r:id="rId15"/>
+    <p:sldId id="266" r:id="rId16"/>
   </p:sldIdLst>
   <p:sldSz cx="12192000" cy="6858000"/>
   <p:notesSz cx="6858000" cy="9144000"/>
@@ -3592,6 +3594,593 @@
 </p:sld>
 </file>
 
+<file path=ppt/slides/slide10.xml><?xml version="1.0" encoding="utf-8"?>
+<p:sld xmlns:a="http://schemas.openxmlformats.org/drawingml/2006/main" xmlns:p="http://schemas.openxmlformats.org/presentationml/2006/main" xmlns:r="http://schemas.openxmlformats.org/officeDocument/2006/relationships">
+  <p:cSld>
+    <p:bg>
+      <p:bgPr>
+        <a:solidFill>
+          <a:srgbClr val="E0F2FE"/>
+        </a:solidFill>
+        <a:effectLst/>
+      </p:bgPr>
+    </p:bg>
+    <p:spTree>
+      <p:nvGrpSpPr>
+        <p:cNvPr id="1" name=""/>
+        <p:cNvGrpSpPr/>
+        <p:nvPr/>
+      </p:nvGrpSpPr>
+      <p:grpSpPr/>
+      <p:grpSp>
+        <p:nvGrpSpPr>
+          <p:cNvPr id="2" name="Group 1"/>
+          <p:cNvGrpSpPr/>
+          <p:nvPr/>
+        </p:nvGrpSpPr>
+        <p:grpSpPr>
+          <a:xfrm>
+            <a:off x="457200" y="1188720"/>
+            <a:ext cx="11247120" cy="4389120"/>
+            <a:chOff x="457200" y="1188720"/>
+            <a:chExt cx="11247120" cy="4389120"/>
+          </a:xfrm>
+        </p:grpSpPr>
+        <p:sp>
+          <p:nvSpPr>
+            <p:cNvPr id="3" name="Rounded Rectangle 2"/>
+            <p:cNvSpPr/>
+            <p:nvPr/>
+          </p:nvSpPr>
+          <p:spPr>
+            <a:xfrm>
+              <a:off x="457200" y="1188720"/>
+              <a:ext cx="11247120" cy="4389120"/>
+            </a:xfrm>
+            <a:prstGeom prst="roundRect">
+              <a:avLst/>
+            </a:prstGeom>
+            <a:solidFill>
+              <a:srgbClr val="FFFFFF"/>
+            </a:solidFill>
+            <a:ln>
+              <a:noFill/>
+            </a:ln>
+          </p:spPr>
+          <p:style>
+            <a:lnRef idx="1">
+              <a:schemeClr val="accent1"/>
+            </a:lnRef>
+            <a:fillRef idx="3">
+              <a:schemeClr val="accent1"/>
+            </a:fillRef>
+            <a:effectRef idx="2">
+              <a:schemeClr val="accent1"/>
+            </a:effectRef>
+            <a:fontRef idx="minor">
+              <a:schemeClr val="lt1"/>
+            </a:fontRef>
+          </p:style>
+          <p:txBody>
+            <a:bodyPr rtlCol="0" anchor="ctr"/>
+            <a:lstStyle/>
+            <a:p>
+              <a:pPr algn="ctr"/>
+            </a:p>
+          </p:txBody>
+        </p:sp>
+        <p:sp>
+          <p:nvSpPr>
+            <p:cNvPr id="4" name="Rectangle 3"/>
+            <p:cNvSpPr/>
+            <p:nvPr/>
+          </p:nvSpPr>
+          <p:spPr>
+            <a:xfrm>
+              <a:off x="457200" y="1188720"/>
+              <a:ext cx="109728" cy="4389120"/>
+            </a:xfrm>
+            <a:prstGeom prst="rect">
+              <a:avLst/>
+            </a:prstGeom>
+            <a:solidFill>
+              <a:srgbClr val="EA580C"/>
+            </a:solidFill>
+            <a:ln>
+              <a:noFill/>
+            </a:ln>
+          </p:spPr>
+          <p:style>
+            <a:lnRef idx="1">
+              <a:schemeClr val="accent1"/>
+            </a:lnRef>
+            <a:fillRef idx="3">
+              <a:schemeClr val="accent1"/>
+            </a:fillRef>
+            <a:effectRef idx="2">
+              <a:schemeClr val="accent1"/>
+            </a:effectRef>
+            <a:fontRef idx="minor">
+              <a:schemeClr val="lt1"/>
+            </a:fontRef>
+          </p:style>
+          <p:txBody>
+            <a:bodyPr rtlCol="0" anchor="ctr"/>
+            <a:lstStyle/>
+            <a:p>
+              <a:pPr algn="ctr"/>
+            </a:p>
+          </p:txBody>
+        </p:sp>
+      </p:grpSp>
+      <p:sp>
+        <p:nvSpPr>
+          <p:cNvPr id="5" name="TextBox 4"/>
+          <p:cNvSpPr txBox="1"/>
+          <p:nvPr/>
+        </p:nvSpPr>
+        <p:spPr>
+          <a:xfrm>
+            <a:off x="914400" y="1371600"/>
+            <a:ext cx="10515600" cy="4023360"/>
+          </a:xfrm>
+          <a:prstGeom prst="rect">
+            <a:avLst/>
+          </a:prstGeom>
+          <a:noFill/>
+        </p:spPr>
+        <p:txBody>
+          <a:bodyPr wrap="square" tIns="91440" bIns="91440">
+            <a:spAutoFit/>
+          </a:bodyPr>
+          <a:lstStyle/>
+          <a:p>
+            <a:pPr algn="l">
+              <a:spcAft>
+                <a:spcPts val="1200"/>
+              </a:spcAft>
+            </a:pPr>
+            <a:r>
+              <a:rPr sz="2400">
+                <a:solidFill>
+                  <a:srgbClr val="EA580C"/>
+                </a:solidFill>
+                <a:latin typeface="Times New Roman"/>
+              </a:rPr>
+              <a:t>📝  Nhiệm vụ mở rộng (Homework)</a:t>
+            </a:r>
+          </a:p>
+          <a:p>
+            <a:pPr algn="l">
+              <a:lnSpc>
+                <a:spcPts val="2800"/>
+              </a:lnSpc>
+              <a:spcAft>
+                <a:spcPts val="800"/>
+              </a:spcAft>
+            </a:pPr>
+            <a:r>
+              <a:rPr sz="1400">
+                <a:solidFill>
+                  <a:srgbClr val="EA580C"/>
+                </a:solidFill>
+                <a:latin typeface="Times New Roman"/>
+              </a:rPr>
+              <a:t>● </a:t>
+            </a:r>
+            <a:r>
+              <a:rPr sz="1800">
+                <a:solidFill>
+                  <a:srgbClr val="1E293B"/>
+                </a:solidFill>
+                <a:latin typeface="Times New Roman"/>
+              </a:rPr>
+              <a:t>Phác thảo ý tưởng 1 mô hình Robot em ước mơ chế tạo.</a:t>
+            </a:r>
+          </a:p>
+          <a:p>
+            <a:pPr algn="l">
+              <a:lnSpc>
+                <a:spcPts val="2800"/>
+              </a:lnSpc>
+              <a:spcAft>
+                <a:spcPts val="800"/>
+              </a:spcAft>
+            </a:pPr>
+            <a:r>
+              <a:rPr sz="1400">
+                <a:solidFill>
+                  <a:srgbClr val="EA580C"/>
+                </a:solidFill>
+                <a:latin typeface="Times New Roman"/>
+              </a:rPr>
+              <a:t>● </a:t>
+            </a:r>
+            <a:r>
+              <a:rPr sz="1800">
+                <a:solidFill>
+                  <a:srgbClr val="1E293B"/>
+                </a:solidFill>
+                <a:latin typeface="Times New Roman"/>
+              </a:rPr>
+              <a:t>Đặt tên và mô tả tính năng chính của Robot đó.</a:t>
+            </a:r>
+          </a:p>
+          <a:p>
+            <a:pPr algn="l">
+              <a:lnSpc>
+                <a:spcPts val="2800"/>
+              </a:lnSpc>
+              <a:spcAft>
+                <a:spcPts val="800"/>
+              </a:spcAft>
+            </a:pPr>
+            <a:r>
+              <a:rPr sz="1400">
+                <a:solidFill>
+                  <a:srgbClr val="EA580C"/>
+                </a:solidFill>
+                <a:latin typeface="Times New Roman"/>
+              </a:rPr>
+              <a:t>● </a:t>
+            </a:r>
+            <a:r>
+              <a:rPr sz="1800">
+                <a:solidFill>
+                  <a:srgbClr val="1E293B"/>
+                </a:solidFill>
+                <a:latin typeface="Times New Roman"/>
+              </a:rPr>
+              <a:t>Cam kết thực hiện đúng nội quy bảo quản bộ Kit Robotics.</a:t>
+            </a:r>
+          </a:p>
+          <a:p>
+            <a:pPr algn="l">
+              <a:lnSpc>
+                <a:spcPts val="2800"/>
+              </a:lnSpc>
+              <a:spcAft>
+                <a:spcPts val="800"/>
+              </a:spcAft>
+            </a:pPr>
+            <a:r>
+              <a:rPr sz="1400">
+                <a:solidFill>
+                  <a:srgbClr val="EA580C"/>
+                </a:solidFill>
+                <a:latin typeface="Times New Roman"/>
+              </a:rPr>
+              <a:t>● </a:t>
+            </a:r>
+            <a:r>
+              <a:rPr sz="1800">
+                <a:solidFill>
+                  <a:srgbClr val="1E293B"/>
+                </a:solidFill>
+                <a:latin typeface="Times New Roman"/>
+              </a:rPr>
+              <a:t>Xem trước Bài 1 trong chương trình Robotics.</a:t>
+            </a:r>
+          </a:p>
+        </p:txBody>
+      </p:sp>
+    </p:spTree>
+  </p:cSld>
+  <p:clrMapOvr>
+    <a:masterClrMapping/>
+  </p:clrMapOvr>
+</p:sld>
+</file>
+
+<file path=ppt/slides/slide11.xml><?xml version="1.0" encoding="utf-8"?>
+<p:sld xmlns:a="http://schemas.openxmlformats.org/drawingml/2006/main" xmlns:p="http://schemas.openxmlformats.org/presentationml/2006/main" xmlns:r="http://schemas.openxmlformats.org/officeDocument/2006/relationships">
+  <p:cSld>
+    <p:bg>
+      <p:bgPr>
+        <a:solidFill>
+          <a:srgbClr val="E0F2FE"/>
+        </a:solidFill>
+        <a:effectLst/>
+      </p:bgPr>
+    </p:bg>
+    <p:spTree>
+      <p:nvGrpSpPr>
+        <p:cNvPr id="1" name=""/>
+        <p:cNvGrpSpPr/>
+        <p:nvPr/>
+      </p:nvGrpSpPr>
+      <p:grpSpPr/>
+      <p:sp>
+        <p:nvSpPr>
+          <p:cNvPr id="2" name="Rectangle 1"/>
+          <p:cNvSpPr/>
+          <p:nvPr/>
+        </p:nvSpPr>
+        <p:spPr>
+          <a:xfrm>
+            <a:off x="0" y="1051560"/>
+            <a:ext cx="12188952" cy="4709160"/>
+          </a:xfrm>
+          <a:prstGeom prst="rect">
+            <a:avLst/>
+          </a:prstGeom>
+          <a:solidFill>
+            <a:srgbClr val="0C4A6E"/>
+          </a:solidFill>
+          <a:ln>
+            <a:noFill/>
+          </a:ln>
+        </p:spPr>
+        <p:style>
+          <a:lnRef idx="1">
+            <a:schemeClr val="accent1"/>
+          </a:lnRef>
+          <a:fillRef idx="3">
+            <a:schemeClr val="accent1"/>
+          </a:fillRef>
+          <a:effectRef idx="2">
+            <a:schemeClr val="accent1"/>
+          </a:effectRef>
+          <a:fontRef idx="minor">
+            <a:schemeClr val="lt1"/>
+          </a:fontRef>
+        </p:style>
+        <p:txBody>
+          <a:bodyPr rtlCol="0" anchor="ctr"/>
+          <a:lstStyle/>
+          <a:p>
+            <a:pPr algn="ctr"/>
+          </a:p>
+        </p:txBody>
+      </p:sp>
+      <p:grpSp>
+        <p:nvGrpSpPr>
+          <p:cNvPr id="3" name="Group 2"/>
+          <p:cNvGrpSpPr/>
+          <p:nvPr/>
+        </p:nvGrpSpPr>
+        <p:grpSpPr>
+          <a:xfrm>
+            <a:off x="1097280" y="1371600"/>
+            <a:ext cx="9966960" cy="4114800"/>
+            <a:chOff x="1097280" y="1371600"/>
+            <a:chExt cx="9966960" cy="4114800"/>
+          </a:xfrm>
+        </p:grpSpPr>
+        <p:sp>
+          <p:nvSpPr>
+            <p:cNvPr id="4" name="Rounded Rectangle 3"/>
+            <p:cNvSpPr/>
+            <p:nvPr/>
+          </p:nvSpPr>
+          <p:spPr>
+            <a:xfrm>
+              <a:off x="1097280" y="1371600"/>
+              <a:ext cx="9966960" cy="4114800"/>
+            </a:xfrm>
+            <a:prstGeom prst="roundRect">
+              <a:avLst/>
+            </a:prstGeom>
+            <a:solidFill>
+              <a:srgbClr val="FFFFFF"/>
+            </a:solidFill>
+            <a:ln>
+              <a:noFill/>
+            </a:ln>
+          </p:spPr>
+          <p:style>
+            <a:lnRef idx="1">
+              <a:schemeClr val="accent1"/>
+            </a:lnRef>
+            <a:fillRef idx="3">
+              <a:schemeClr val="accent1"/>
+            </a:fillRef>
+            <a:effectRef idx="2">
+              <a:schemeClr val="accent1"/>
+            </a:effectRef>
+            <a:fontRef idx="minor">
+              <a:schemeClr val="lt1"/>
+            </a:fontRef>
+          </p:style>
+          <p:txBody>
+            <a:bodyPr rtlCol="0" anchor="ctr"/>
+            <a:lstStyle/>
+            <a:p>
+              <a:pPr algn="ctr"/>
+            </a:p>
+          </p:txBody>
+        </p:sp>
+        <p:sp>
+          <p:nvSpPr>
+            <p:cNvPr id="5" name="Rectangle 4"/>
+            <p:cNvSpPr/>
+            <p:nvPr/>
+          </p:nvSpPr>
+          <p:spPr>
+            <a:xfrm>
+              <a:off x="1097280" y="1371600"/>
+              <a:ext cx="164592" cy="4114800"/>
+            </a:xfrm>
+            <a:prstGeom prst="rect">
+              <a:avLst/>
+            </a:prstGeom>
+            <a:solidFill>
+              <a:srgbClr val="EA580C"/>
+            </a:solidFill>
+            <a:ln>
+              <a:noFill/>
+            </a:ln>
+          </p:spPr>
+          <p:style>
+            <a:lnRef idx="1">
+              <a:schemeClr val="accent1"/>
+            </a:lnRef>
+            <a:fillRef idx="3">
+              <a:schemeClr val="accent1"/>
+            </a:fillRef>
+            <a:effectRef idx="2">
+              <a:schemeClr val="accent1"/>
+            </a:effectRef>
+            <a:fontRef idx="minor">
+              <a:schemeClr val="lt1"/>
+            </a:fontRef>
+          </p:style>
+          <p:txBody>
+            <a:bodyPr rtlCol="0" anchor="ctr"/>
+            <a:lstStyle/>
+            <a:p>
+              <a:pPr algn="ctr"/>
+            </a:p>
+          </p:txBody>
+        </p:sp>
+      </p:grpSp>
+      <p:sp>
+        <p:nvSpPr>
+          <p:cNvPr id="6" name="TextBox 5"/>
+          <p:cNvSpPr txBox="1"/>
+          <p:nvPr/>
+        </p:nvSpPr>
+        <p:spPr>
+          <a:xfrm>
+            <a:off x="1554480" y="1554480"/>
+            <a:ext cx="9144000" cy="3657600"/>
+          </a:xfrm>
+          <a:prstGeom prst="rect">
+            <a:avLst/>
+          </a:prstGeom>
+          <a:noFill/>
+        </p:spPr>
+        <p:txBody>
+          <a:bodyPr wrap="square" tIns="91440" bIns="91440">
+            <a:spAutoFit/>
+          </a:bodyPr>
+          <a:lstStyle/>
+          <a:p>
+            <a:pPr algn="l">
+              <a:spcAft>
+                <a:spcPts val="1200"/>
+              </a:spcAft>
+            </a:pPr>
+            <a:r>
+              <a:rPr sz="2400">
+                <a:solidFill>
+                  <a:srgbClr val="0C4A6E"/>
+                </a:solidFill>
+                <a:latin typeface="Times New Roman"/>
+              </a:rPr>
+              <a:t>📌  Ghi nhớ — Robotics Lớp 1</a:t>
+            </a:r>
+          </a:p>
+          <a:p>
+            <a:pPr algn="l">
+              <a:lnSpc>
+                <a:spcPts val="2800"/>
+              </a:lnSpc>
+              <a:spcAft>
+                <a:spcPts val="800"/>
+              </a:spcAft>
+            </a:pPr>
+            <a:r>
+              <a:rPr sz="1400">
+                <a:solidFill>
+                  <a:srgbClr val="EA580C"/>
+                </a:solidFill>
+                <a:latin typeface="Times New Roman"/>
+              </a:rPr>
+              <a:t>● </a:t>
+            </a:r>
+            <a:r>
+              <a:rPr sz="1800">
+                <a:solidFill>
+                  <a:srgbClr val="1E293B"/>
+                </a:solidFill>
+                <a:latin typeface="Times New Roman"/>
+              </a:rPr>
+              <a:t>Robotics giúp em tự tay biến ý tưởng thành hiện thực.</a:t>
+            </a:r>
+          </a:p>
+          <a:p>
+            <a:pPr algn="l">
+              <a:lnSpc>
+                <a:spcPts val="2800"/>
+              </a:lnSpc>
+              <a:spcAft>
+                <a:spcPts val="800"/>
+              </a:spcAft>
+            </a:pPr>
+            <a:r>
+              <a:rPr sz="1400">
+                <a:solidFill>
+                  <a:srgbClr val="EA580C"/>
+                </a:solidFill>
+                <a:latin typeface="Times New Roman"/>
+              </a:rPr>
+              <a:t>● </a:t>
+            </a:r>
+            <a:r>
+              <a:rPr sz="1800">
+                <a:solidFill>
+                  <a:srgbClr val="1E293B"/>
+                </a:solidFill>
+                <a:latin typeface="Times New Roman"/>
+              </a:rPr>
+              <a:t>Cẩn thận, tỉ mỉ &amp; tuân thủ an toàn thiết bị.</a:t>
+            </a:r>
+          </a:p>
+          <a:p>
+            <a:pPr algn="l">
+              <a:lnSpc>
+                <a:spcPts val="2800"/>
+              </a:lnSpc>
+              <a:spcAft>
+                <a:spcPts val="800"/>
+              </a:spcAft>
+            </a:pPr>
+            <a:r>
+              <a:rPr sz="1400">
+                <a:solidFill>
+                  <a:srgbClr val="EA580C"/>
+                </a:solidFill>
+                <a:latin typeface="Times New Roman"/>
+              </a:rPr>
+              <a:t>● </a:t>
+            </a:r>
+            <a:r>
+              <a:rPr sz="1800">
+                <a:solidFill>
+                  <a:srgbClr val="1E293B"/>
+                </a:solidFill>
+                <a:latin typeface="Times New Roman"/>
+              </a:rPr>
+              <a:t>Đam mê sáng tạo — Chinh phục công nghệ!</a:t>
+            </a:r>
+          </a:p>
+          <a:p>
+            <a:pPr algn="ctr">
+              <a:spcBef>
+                <a:spcPts val="2000"/>
+              </a:spcBef>
+            </a:pPr>
+            <a:r>
+              <a:rPr sz="2200">
+                <a:solidFill>
+                  <a:srgbClr val="0284C7"/>
+                </a:solidFill>
+                <a:latin typeface="Times New Roman"/>
+              </a:rPr>
+              <a:t>Chúc các em một năm học Robotics bùng nổ! 🚀🤖</a:t>
+            </a:r>
+          </a:p>
+        </p:txBody>
+      </p:sp>
+    </p:spTree>
+  </p:cSld>
+  <p:clrMapOvr>
+    <a:masterClrMapping/>
+  </p:clrMapOvr>
+</p:sld>
+</file>
+
 <file path=ppt/slides/slide2.xml><?xml version="1.0" encoding="utf-8"?>
 <p:sld xmlns:a="http://schemas.openxmlformats.org/drawingml/2006/main" xmlns:p="http://schemas.openxmlformats.org/presentationml/2006/main" xmlns:r="http://schemas.openxmlformats.org/officeDocument/2006/relationships">
   <p:cSld>
@@ -4666,30 +5255,54 @@
         <p:nvPr/>
       </p:nvGrpSpPr>
       <p:grpSpPr/>
+      <p:pic>
+        <p:nvPicPr>
+          <p:cNvPr id="2" name="Picture 1" descr="rules_kit_ollo.png"/>
+          <p:cNvPicPr>
+            <a:picLocks noChangeAspect="1"/>
+          </p:cNvPicPr>
+          <p:nvPr/>
+        </p:nvPicPr>
+        <p:blipFill>
+          <a:blip r:embed="rId2"/>
+          <a:stretch>
+            <a:fillRect/>
+          </a:stretch>
+        </p:blipFill>
+        <p:spPr>
+          <a:xfrm>
+            <a:off x="6583680" y="1188720"/>
+            <a:ext cx="4937760" cy="4389120"/>
+          </a:xfrm>
+          <a:prstGeom prst="rect">
+            <a:avLst/>
+          </a:prstGeom>
+        </p:spPr>
+      </p:pic>
       <p:grpSp>
         <p:nvGrpSpPr>
-          <p:cNvPr id="2" name="Group 1"/>
+          <p:cNvPr id="3" name="Group 2"/>
           <p:cNvGrpSpPr/>
           <p:nvPr/>
         </p:nvGrpSpPr>
         <p:grpSpPr>
           <a:xfrm>
             <a:off x="457200" y="1188720"/>
-            <a:ext cx="11247120" cy="4389120"/>
+            <a:ext cx="5760720" cy="4389120"/>
             <a:chOff x="457200" y="1188720"/>
-            <a:chExt cx="11247120" cy="4389120"/>
+            <a:chExt cx="5760720" cy="4389120"/>
           </a:xfrm>
         </p:grpSpPr>
         <p:sp>
           <p:nvSpPr>
-            <p:cNvPr id="3" name="Rounded Rectangle 2"/>
+            <p:cNvPr id="4" name="Rounded Rectangle 3"/>
             <p:cNvSpPr/>
             <p:nvPr/>
           </p:nvSpPr>
           <p:spPr>
             <a:xfrm>
               <a:off x="457200" y="1188720"/>
-              <a:ext cx="11247120" cy="4389120"/>
+              <a:ext cx="5760720" cy="4389120"/>
             </a:xfrm>
             <a:prstGeom prst="roundRect">
               <a:avLst/>
@@ -4725,7 +5338,7 @@
         </p:sp>
         <p:sp>
           <p:nvSpPr>
-            <p:cNvPr id="4" name="Rectangle 3"/>
+            <p:cNvPr id="5" name="Rectangle 4"/>
             <p:cNvSpPr/>
             <p:nvPr/>
           </p:nvSpPr>
@@ -4769,14 +5382,14 @@
       </p:grpSp>
       <p:sp>
         <p:nvSpPr>
-          <p:cNvPr id="5" name="TextBox 4"/>
+          <p:cNvPr id="6" name="TextBox 5"/>
           <p:cNvSpPr txBox="1"/>
           <p:nvPr/>
         </p:nvSpPr>
         <p:spPr>
           <a:xfrm>
             <a:off x="914400" y="1371600"/>
-            <a:ext cx="10515600" cy="4023360"/>
+            <a:ext cx="5120640" cy="4023360"/>
           </a:xfrm>
           <a:prstGeom prst="rect">
             <a:avLst/>
@@ -4795,13 +5408,13 @@
               </a:spcAft>
             </a:pPr>
             <a:r>
-              <a:rPr sz="2400">
+              <a:rPr sz="2200">
                 <a:solidFill>
                   <a:srgbClr val="B91C1C"/>
                 </a:solidFill>
                 <a:latin typeface="Times New Roman"/>
               </a:rPr>
-              <a:t>⚠️  Nội quy phòng Thực hành Robotics</a:t>
+              <a:t>⚠️  II. Quy định Kit OLLO</a:t>
             </a:r>
           </a:p>
           <a:p>
@@ -4823,13 +5436,13 @@
               <a:t>● </a:t>
             </a:r>
             <a:r>
-              <a:rPr sz="1800">
+              <a:rPr sz="1600">
                 <a:solidFill>
                   <a:srgbClr val="1E293B"/>
                 </a:solidFill>
                 <a:latin typeface="Times New Roman"/>
               </a:rPr>
-              <a:t>Bảo quản bộ Kit Robotics: Phân loại chi tiết đúng ô khay đựng.</a:t>
+              <a:t>Dùng dụng cụ tháo rivet chuyên dụng; không dùng răng/móng tay cạy.</a:t>
             </a:r>
           </a:p>
           <a:p>
@@ -4851,13 +5464,13 @@
               <a:t>● </a:t>
             </a:r>
             <a:r>
-              <a:rPr sz="1800">
+              <a:rPr sz="1600">
                 <a:solidFill>
                   <a:srgbClr val="1E293B"/>
                 </a:solidFill>
                 <a:latin typeface="Times New Roman"/>
               </a:rPr>
-              <a:t>KHÔNG làm rơi vỡ động cơ, cảm biến hay mạch điều khiển.</a:t>
+              <a:t>Làm việc trên khay/hộp; không để linh kiện rơi xuống sàn.</a:t>
             </a:r>
           </a:p>
           <a:p>
@@ -4879,13 +5492,13 @@
               <a:t>● </a:t>
             </a:r>
             <a:r>
-              <a:rPr sz="1800">
+              <a:rPr sz="1600">
                 <a:solidFill>
                   <a:srgbClr val="1E293B"/>
                 </a:solidFill>
                 <a:latin typeface="Times New Roman"/>
               </a:rPr>
-              <a:t>Tắt nguồn pin/bộ điều khiển sau khi kết thúc giờ thực hành.</a:t>
+              <a:t>Cắm/rút dây cáp nhẹ nhàng, thẳng góc vào đúng cổng.</a:t>
             </a:r>
           </a:p>
           <a:p>
@@ -4907,13 +5520,13 @@
               <a:t>● </a:t>
             </a:r>
             <a:r>
-              <a:rPr sz="1800">
+              <a:rPr sz="1600">
                 <a:solidFill>
                   <a:srgbClr val="1E293B"/>
                 </a:solidFill>
                 <a:latin typeface="Times New Roman"/>
               </a:rPr>
-              <a:t>Gặp sự cố kỹ thuật → BÁO NGAY cho Giáo viên hướng dẫn.</a:t>
+              <a:t>Tắt nguồn khi lắp ráp; báo ngay nếu pin nóng/phồng bất thường.</a:t>
             </a:r>
           </a:p>
         </p:txBody>
@@ -4927,6 +5540,582 @@
 </file>
 
 <file path=ppt/slides/slide7.xml><?xml version="1.0" encoding="utf-8"?>
+<p:sld xmlns:a="http://schemas.openxmlformats.org/drawingml/2006/main" xmlns:p="http://schemas.openxmlformats.org/presentationml/2006/main" xmlns:r="http://schemas.openxmlformats.org/officeDocument/2006/relationships">
+  <p:cSld>
+    <p:bg>
+      <p:bgPr>
+        <a:solidFill>
+          <a:srgbClr val="E0F2FE"/>
+        </a:solidFill>
+        <a:effectLst/>
+      </p:bgPr>
+    </p:bg>
+    <p:spTree>
+      <p:nvGrpSpPr>
+        <p:cNvPr id="1" name=""/>
+        <p:cNvGrpSpPr/>
+        <p:nvPr/>
+      </p:nvGrpSpPr>
+      <p:grpSpPr/>
+      <p:pic>
+        <p:nvPicPr>
+          <p:cNvPr id="2" name="Picture 1" descr="rules_during_class.png"/>
+          <p:cNvPicPr>
+            <a:picLocks noChangeAspect="1"/>
+          </p:cNvPicPr>
+          <p:nvPr/>
+        </p:nvPicPr>
+        <p:blipFill>
+          <a:blip r:embed="rId2"/>
+          <a:stretch>
+            <a:fillRect/>
+          </a:stretch>
+        </p:blipFill>
+        <p:spPr>
+          <a:xfrm>
+            <a:off x="6583680" y="1188720"/>
+            <a:ext cx="4937760" cy="4389120"/>
+          </a:xfrm>
+          <a:prstGeom prst="rect">
+            <a:avLst/>
+          </a:prstGeom>
+        </p:spPr>
+      </p:pic>
+      <p:grpSp>
+        <p:nvGrpSpPr>
+          <p:cNvPr id="3" name="Group 2"/>
+          <p:cNvGrpSpPr/>
+          <p:nvPr/>
+        </p:nvGrpSpPr>
+        <p:grpSpPr>
+          <a:xfrm>
+            <a:off x="457200" y="1188720"/>
+            <a:ext cx="5760720" cy="4389120"/>
+            <a:chOff x="457200" y="1188720"/>
+            <a:chExt cx="5760720" cy="4389120"/>
+          </a:xfrm>
+        </p:grpSpPr>
+        <p:sp>
+          <p:nvSpPr>
+            <p:cNvPr id="4" name="Rounded Rectangle 3"/>
+            <p:cNvSpPr/>
+            <p:nvPr/>
+          </p:nvSpPr>
+          <p:spPr>
+            <a:xfrm>
+              <a:off x="457200" y="1188720"/>
+              <a:ext cx="5760720" cy="4389120"/>
+            </a:xfrm>
+            <a:prstGeom prst="roundRect">
+              <a:avLst/>
+            </a:prstGeom>
+            <a:solidFill>
+              <a:srgbClr val="FFFFFF"/>
+            </a:solidFill>
+            <a:ln>
+              <a:noFill/>
+            </a:ln>
+          </p:spPr>
+          <p:style>
+            <a:lnRef idx="1">
+              <a:schemeClr val="accent1"/>
+            </a:lnRef>
+            <a:fillRef idx="3">
+              <a:schemeClr val="accent1"/>
+            </a:fillRef>
+            <a:effectRef idx="2">
+              <a:schemeClr val="accent1"/>
+            </a:effectRef>
+            <a:fontRef idx="minor">
+              <a:schemeClr val="lt1"/>
+            </a:fontRef>
+          </p:style>
+          <p:txBody>
+            <a:bodyPr rtlCol="0" anchor="ctr"/>
+            <a:lstStyle/>
+            <a:p>
+              <a:pPr algn="ctr"/>
+            </a:p>
+          </p:txBody>
+        </p:sp>
+        <p:sp>
+          <p:nvSpPr>
+            <p:cNvPr id="5" name="Rectangle 4"/>
+            <p:cNvSpPr/>
+            <p:nvPr/>
+          </p:nvSpPr>
+          <p:spPr>
+            <a:xfrm>
+              <a:off x="457200" y="1188720"/>
+              <a:ext cx="109728" cy="4389120"/>
+            </a:xfrm>
+            <a:prstGeom prst="rect">
+              <a:avLst/>
+            </a:prstGeom>
+            <a:solidFill>
+              <a:srgbClr val="B91C1C"/>
+            </a:solidFill>
+            <a:ln>
+              <a:noFill/>
+            </a:ln>
+          </p:spPr>
+          <p:style>
+            <a:lnRef idx="1">
+              <a:schemeClr val="accent1"/>
+            </a:lnRef>
+            <a:fillRef idx="3">
+              <a:schemeClr val="accent1"/>
+            </a:fillRef>
+            <a:effectRef idx="2">
+              <a:schemeClr val="accent1"/>
+            </a:effectRef>
+            <a:fontRef idx="minor">
+              <a:schemeClr val="lt1"/>
+            </a:fontRef>
+          </p:style>
+          <p:txBody>
+            <a:bodyPr rtlCol="0" anchor="ctr"/>
+            <a:lstStyle/>
+            <a:p>
+              <a:pPr algn="ctr"/>
+            </a:p>
+          </p:txBody>
+        </p:sp>
+      </p:grpSp>
+      <p:sp>
+        <p:nvSpPr>
+          <p:cNvPr id="6" name="TextBox 5"/>
+          <p:cNvSpPr txBox="1"/>
+          <p:nvPr/>
+        </p:nvSpPr>
+        <p:spPr>
+          <a:xfrm>
+            <a:off x="914400" y="1371600"/>
+            <a:ext cx="5120640" cy="4023360"/>
+          </a:xfrm>
+          <a:prstGeom prst="rect">
+            <a:avLst/>
+          </a:prstGeom>
+          <a:noFill/>
+        </p:spPr>
+        <p:txBody>
+          <a:bodyPr wrap="square" tIns="91440" bIns="91440">
+            <a:spAutoFit/>
+          </a:bodyPr>
+          <a:lstStyle/>
+          <a:p>
+            <a:pPr algn="l">
+              <a:spcAft>
+                <a:spcPts val="1200"/>
+              </a:spcAft>
+            </a:pPr>
+            <a:r>
+              <a:rPr sz="2200">
+                <a:solidFill>
+                  <a:srgbClr val="B91C1C"/>
+                </a:solidFill>
+                <a:latin typeface="Times New Roman"/>
+              </a:rPr>
+              <a:t>⚠️  III. Trong giờ học</a:t>
+            </a:r>
+          </a:p>
+          <a:p>
+            <a:pPr algn="l">
+              <a:lnSpc>
+                <a:spcPts val="2800"/>
+              </a:lnSpc>
+              <a:spcAft>
+                <a:spcPts val="800"/>
+              </a:spcAft>
+            </a:pPr>
+            <a:r>
+              <a:rPr sz="1400">
+                <a:solidFill>
+                  <a:srgbClr val="B91C1C"/>
+                </a:solidFill>
+                <a:latin typeface="Times New Roman"/>
+              </a:rPr>
+              <a:t>● </a:t>
+            </a:r>
+            <a:r>
+              <a:rPr sz="1800">
+                <a:solidFill>
+                  <a:srgbClr val="1E293B"/>
+                </a:solidFill>
+                <a:latin typeface="Times New Roman"/>
+              </a:rPr>
+              <a:t>Ngồi đúng vị trí nhóm/cá nhân được phân công.</a:t>
+            </a:r>
+          </a:p>
+          <a:p>
+            <a:pPr algn="l">
+              <a:lnSpc>
+                <a:spcPts val="2800"/>
+              </a:lnSpc>
+              <a:spcAft>
+                <a:spcPts val="800"/>
+              </a:spcAft>
+            </a:pPr>
+            <a:r>
+              <a:rPr sz="1400">
+                <a:solidFill>
+                  <a:srgbClr val="B91C1C"/>
+                </a:solidFill>
+                <a:latin typeface="Times New Roman"/>
+              </a:rPr>
+              <a:t>● </a:t>
+            </a:r>
+            <a:r>
+              <a:rPr sz="1800">
+                <a:solidFill>
+                  <a:srgbClr val="1E293B"/>
+                </a:solidFill>
+                <a:latin typeface="Times New Roman"/>
+              </a:rPr>
+              <a:t>Thử nghiệm Robot trên thảm/bàn chuyên dụng, không cho chạy dưới sàn.</a:t>
+            </a:r>
+          </a:p>
+          <a:p>
+            <a:pPr algn="l">
+              <a:lnSpc>
+                <a:spcPts val="2800"/>
+              </a:lnSpc>
+              <a:spcAft>
+                <a:spcPts val="800"/>
+              </a:spcAft>
+            </a:pPr>
+            <a:r>
+              <a:rPr sz="1400">
+                <a:solidFill>
+                  <a:srgbClr val="B91C1C"/>
+                </a:solidFill>
+                <a:latin typeface="Times New Roman"/>
+              </a:rPr>
+              <a:t>● </a:t>
+            </a:r>
+            <a:r>
+              <a:rPr sz="1800">
+                <a:solidFill>
+                  <a:srgbClr val="1E293B"/>
+                </a:solidFill>
+                <a:latin typeface="Times New Roman"/>
+              </a:rPr>
+              <a:t>Chỉ dùng phần mềm được chỉ định (R+ Task, ROBOTIS BLOCK...).</a:t>
+            </a:r>
+          </a:p>
+        </p:txBody>
+      </p:sp>
+    </p:spTree>
+  </p:cSld>
+  <p:clrMapOvr>
+    <a:masterClrMapping/>
+  </p:clrMapOvr>
+</p:sld>
+</file>
+
+<file path=ppt/slides/slide8.xml><?xml version="1.0" encoding="utf-8"?>
+<p:sld xmlns:a="http://schemas.openxmlformats.org/drawingml/2006/main" xmlns:p="http://schemas.openxmlformats.org/presentationml/2006/main" xmlns:r="http://schemas.openxmlformats.org/officeDocument/2006/relationships">
+  <p:cSld>
+    <p:bg>
+      <p:bgPr>
+        <a:solidFill>
+          <a:srgbClr val="E0F2FE"/>
+        </a:solidFill>
+        <a:effectLst/>
+      </p:bgPr>
+    </p:bg>
+    <p:spTree>
+      <p:nvGrpSpPr>
+        <p:cNvPr id="1" name=""/>
+        <p:cNvGrpSpPr/>
+        <p:nvPr/>
+      </p:nvGrpSpPr>
+      <p:grpSpPr/>
+      <p:pic>
+        <p:nvPicPr>
+          <p:cNvPr id="2" name="Picture 1" descr="rules_after_class.png"/>
+          <p:cNvPicPr>
+            <a:picLocks noChangeAspect="1"/>
+          </p:cNvPicPr>
+          <p:nvPr/>
+        </p:nvPicPr>
+        <p:blipFill>
+          <a:blip r:embed="rId2"/>
+          <a:stretch>
+            <a:fillRect/>
+          </a:stretch>
+        </p:blipFill>
+        <p:spPr>
+          <a:xfrm>
+            <a:off x="6583680" y="1188720"/>
+            <a:ext cx="4937760" cy="4389120"/>
+          </a:xfrm>
+          <a:prstGeom prst="rect">
+            <a:avLst/>
+          </a:prstGeom>
+        </p:spPr>
+      </p:pic>
+      <p:grpSp>
+        <p:nvGrpSpPr>
+          <p:cNvPr id="3" name="Group 2"/>
+          <p:cNvGrpSpPr/>
+          <p:nvPr/>
+        </p:nvGrpSpPr>
+        <p:grpSpPr>
+          <a:xfrm>
+            <a:off x="457200" y="1188720"/>
+            <a:ext cx="5760720" cy="4389120"/>
+            <a:chOff x="457200" y="1188720"/>
+            <a:chExt cx="5760720" cy="4389120"/>
+          </a:xfrm>
+        </p:grpSpPr>
+        <p:sp>
+          <p:nvSpPr>
+            <p:cNvPr id="4" name="Rounded Rectangle 3"/>
+            <p:cNvSpPr/>
+            <p:nvPr/>
+          </p:nvSpPr>
+          <p:spPr>
+            <a:xfrm>
+              <a:off x="457200" y="1188720"/>
+              <a:ext cx="5760720" cy="4389120"/>
+            </a:xfrm>
+            <a:prstGeom prst="roundRect">
+              <a:avLst/>
+            </a:prstGeom>
+            <a:solidFill>
+              <a:srgbClr val="FFFFFF"/>
+            </a:solidFill>
+            <a:ln>
+              <a:noFill/>
+            </a:ln>
+          </p:spPr>
+          <p:style>
+            <a:lnRef idx="1">
+              <a:schemeClr val="accent1"/>
+            </a:lnRef>
+            <a:fillRef idx="3">
+              <a:schemeClr val="accent1"/>
+            </a:fillRef>
+            <a:effectRef idx="2">
+              <a:schemeClr val="accent1"/>
+            </a:effectRef>
+            <a:fontRef idx="minor">
+              <a:schemeClr val="lt1"/>
+            </a:fontRef>
+          </p:style>
+          <p:txBody>
+            <a:bodyPr rtlCol="0" anchor="ctr"/>
+            <a:lstStyle/>
+            <a:p>
+              <a:pPr algn="ctr"/>
+            </a:p>
+          </p:txBody>
+        </p:sp>
+        <p:sp>
+          <p:nvSpPr>
+            <p:cNvPr id="5" name="Rectangle 4"/>
+            <p:cNvSpPr/>
+            <p:nvPr/>
+          </p:nvSpPr>
+          <p:spPr>
+            <a:xfrm>
+              <a:off x="457200" y="1188720"/>
+              <a:ext cx="109728" cy="4389120"/>
+            </a:xfrm>
+            <a:prstGeom prst="rect">
+              <a:avLst/>
+            </a:prstGeom>
+            <a:solidFill>
+              <a:srgbClr val="B91C1C"/>
+            </a:solidFill>
+            <a:ln>
+              <a:noFill/>
+            </a:ln>
+          </p:spPr>
+          <p:style>
+            <a:lnRef idx="1">
+              <a:schemeClr val="accent1"/>
+            </a:lnRef>
+            <a:fillRef idx="3">
+              <a:schemeClr val="accent1"/>
+            </a:fillRef>
+            <a:effectRef idx="2">
+              <a:schemeClr val="accent1"/>
+            </a:effectRef>
+            <a:fontRef idx="minor">
+              <a:schemeClr val="lt1"/>
+            </a:fontRef>
+          </p:style>
+          <p:txBody>
+            <a:bodyPr rtlCol="0" anchor="ctr"/>
+            <a:lstStyle/>
+            <a:p>
+              <a:pPr algn="ctr"/>
+            </a:p>
+          </p:txBody>
+        </p:sp>
+      </p:grpSp>
+      <p:sp>
+        <p:nvSpPr>
+          <p:cNvPr id="6" name="TextBox 5"/>
+          <p:cNvSpPr txBox="1"/>
+          <p:nvPr/>
+        </p:nvSpPr>
+        <p:spPr>
+          <a:xfrm>
+            <a:off x="914400" y="1371600"/>
+            <a:ext cx="5120640" cy="4023360"/>
+          </a:xfrm>
+          <a:prstGeom prst="rect">
+            <a:avLst/>
+          </a:prstGeom>
+          <a:noFill/>
+        </p:spPr>
+        <p:txBody>
+          <a:bodyPr wrap="square" tIns="91440" bIns="91440">
+            <a:spAutoFit/>
+          </a:bodyPr>
+          <a:lstStyle/>
+          <a:p>
+            <a:pPr algn="l">
+              <a:spcAft>
+                <a:spcPts val="1200"/>
+              </a:spcAft>
+            </a:pPr>
+            <a:r>
+              <a:rPr sz="2200">
+                <a:solidFill>
+                  <a:srgbClr val="B91C1C"/>
+                </a:solidFill>
+                <a:latin typeface="Times New Roman"/>
+              </a:rPr>
+              <a:t>⚠️  IV. Sau thực hành</a:t>
+            </a:r>
+          </a:p>
+          <a:p>
+            <a:pPr algn="l">
+              <a:lnSpc>
+                <a:spcPts val="2800"/>
+              </a:lnSpc>
+              <a:spcAft>
+                <a:spcPts val="800"/>
+              </a:spcAft>
+            </a:pPr>
+            <a:r>
+              <a:rPr sz="1400">
+                <a:solidFill>
+                  <a:srgbClr val="B91C1C"/>
+                </a:solidFill>
+                <a:latin typeface="Times New Roman"/>
+              </a:rPr>
+              <a:t>● </a:t>
+            </a:r>
+            <a:r>
+              <a:rPr sz="1600">
+                <a:solidFill>
+                  <a:srgbClr val="1E293B"/>
+                </a:solidFill>
+                <a:latin typeface="Times New Roman"/>
+              </a:rPr>
+              <a:t>Tháo dỡ Robot nhẹ nhàng; phân loại linh kiện về đúng ngăn hộp.</a:t>
+            </a:r>
+          </a:p>
+          <a:p>
+            <a:pPr algn="l">
+              <a:lnSpc>
+                <a:spcPts val="2800"/>
+              </a:lnSpc>
+              <a:spcAft>
+                <a:spcPts val="800"/>
+              </a:spcAft>
+            </a:pPr>
+            <a:r>
+              <a:rPr sz="1400">
+                <a:solidFill>
+                  <a:srgbClr val="B91C1C"/>
+                </a:solidFill>
+                <a:latin typeface="Times New Roman"/>
+              </a:rPr>
+              <a:t>● </a:t>
+            </a:r>
+            <a:r>
+              <a:rPr sz="1600">
+                <a:solidFill>
+                  <a:srgbClr val="1E293B"/>
+                </a:solidFill>
+                <a:latin typeface="Times New Roman"/>
+              </a:rPr>
+              <a:t>Tắt nguồn Robot, tháo dây sạc/kết nối.</a:t>
+            </a:r>
+          </a:p>
+          <a:p>
+            <a:pPr algn="l">
+              <a:lnSpc>
+                <a:spcPts val="2800"/>
+              </a:lnSpc>
+              <a:spcAft>
+                <a:spcPts val="800"/>
+              </a:spcAft>
+            </a:pPr>
+            <a:r>
+              <a:rPr sz="1400">
+                <a:solidFill>
+                  <a:srgbClr val="B91C1C"/>
+                </a:solidFill>
+                <a:latin typeface="Times New Roman"/>
+              </a:rPr>
+              <a:t>● </a:t>
+            </a:r>
+            <a:r>
+              <a:rPr sz="1600">
+                <a:solidFill>
+                  <a:srgbClr val="1E293B"/>
+                </a:solidFill>
+                <a:latin typeface="Times New Roman"/>
+              </a:rPr>
+              <a:t>Kiểm tra đủ số lượng linh kiện cùng giáo viên trước khi rời.</a:t>
+            </a:r>
+          </a:p>
+          <a:p>
+            <a:pPr algn="l">
+              <a:lnSpc>
+                <a:spcPts val="2800"/>
+              </a:lnSpc>
+              <a:spcAft>
+                <a:spcPts val="800"/>
+              </a:spcAft>
+            </a:pPr>
+            <a:r>
+              <a:rPr sz="1400">
+                <a:solidFill>
+                  <a:srgbClr val="B91C1C"/>
+                </a:solidFill>
+                <a:latin typeface="Times New Roman"/>
+              </a:rPr>
+              <a:t>● </a:t>
+            </a:r>
+            <a:r>
+              <a:rPr sz="1600">
+                <a:solidFill>
+                  <a:srgbClr val="1E293B"/>
+                </a:solidFill>
+                <a:latin typeface="Times New Roman"/>
+              </a:rPr>
+              <a:t>Vệ sinh mặt bàn, thu dọn rác và xếp ghế gọn gàng.</a:t>
+            </a:r>
+          </a:p>
+        </p:txBody>
+      </p:sp>
+    </p:spTree>
+  </p:cSld>
+  <p:clrMapOvr>
+    <a:masterClrMapping/>
+  </p:clrMapOvr>
+</p:sld>
+</file>
+
+<file path=ppt/slides/slide9.xml><?xml version="1.0" encoding="utf-8"?>
 <p:sld xmlns:a="http://schemas.openxmlformats.org/drawingml/2006/main" xmlns:p="http://schemas.openxmlformats.org/presentationml/2006/main" xmlns:r="http://schemas.openxmlformats.org/officeDocument/2006/relationships">
   <p:cSld>
     <p:bg>
@@ -5388,593 +6577,6 @@
                 <a:latin typeface="Times New Roman"/>
               </a:rPr>
               <a:t>Máy tính/Máy tính bảng lập trình.</a:t>
-            </a:r>
-          </a:p>
-        </p:txBody>
-      </p:sp>
-    </p:spTree>
-  </p:cSld>
-  <p:clrMapOvr>
-    <a:masterClrMapping/>
-  </p:clrMapOvr>
-</p:sld>
-</file>
-
-<file path=ppt/slides/slide8.xml><?xml version="1.0" encoding="utf-8"?>
-<p:sld xmlns:a="http://schemas.openxmlformats.org/drawingml/2006/main" xmlns:p="http://schemas.openxmlformats.org/presentationml/2006/main" xmlns:r="http://schemas.openxmlformats.org/officeDocument/2006/relationships">
-  <p:cSld>
-    <p:bg>
-      <p:bgPr>
-        <a:solidFill>
-          <a:srgbClr val="E0F2FE"/>
-        </a:solidFill>
-        <a:effectLst/>
-      </p:bgPr>
-    </p:bg>
-    <p:spTree>
-      <p:nvGrpSpPr>
-        <p:cNvPr id="1" name=""/>
-        <p:cNvGrpSpPr/>
-        <p:nvPr/>
-      </p:nvGrpSpPr>
-      <p:grpSpPr/>
-      <p:grpSp>
-        <p:nvGrpSpPr>
-          <p:cNvPr id="2" name="Group 1"/>
-          <p:cNvGrpSpPr/>
-          <p:nvPr/>
-        </p:nvGrpSpPr>
-        <p:grpSpPr>
-          <a:xfrm>
-            <a:off x="457200" y="1188720"/>
-            <a:ext cx="11247120" cy="4389120"/>
-            <a:chOff x="457200" y="1188720"/>
-            <a:chExt cx="11247120" cy="4389120"/>
-          </a:xfrm>
-        </p:grpSpPr>
-        <p:sp>
-          <p:nvSpPr>
-            <p:cNvPr id="3" name="Rounded Rectangle 2"/>
-            <p:cNvSpPr/>
-            <p:nvPr/>
-          </p:nvSpPr>
-          <p:spPr>
-            <a:xfrm>
-              <a:off x="457200" y="1188720"/>
-              <a:ext cx="11247120" cy="4389120"/>
-            </a:xfrm>
-            <a:prstGeom prst="roundRect">
-              <a:avLst/>
-            </a:prstGeom>
-            <a:solidFill>
-              <a:srgbClr val="FFFFFF"/>
-            </a:solidFill>
-            <a:ln>
-              <a:noFill/>
-            </a:ln>
-          </p:spPr>
-          <p:style>
-            <a:lnRef idx="1">
-              <a:schemeClr val="accent1"/>
-            </a:lnRef>
-            <a:fillRef idx="3">
-              <a:schemeClr val="accent1"/>
-            </a:fillRef>
-            <a:effectRef idx="2">
-              <a:schemeClr val="accent1"/>
-            </a:effectRef>
-            <a:fontRef idx="minor">
-              <a:schemeClr val="lt1"/>
-            </a:fontRef>
-          </p:style>
-          <p:txBody>
-            <a:bodyPr rtlCol="0" anchor="ctr"/>
-            <a:lstStyle/>
-            <a:p>
-              <a:pPr algn="ctr"/>
-            </a:p>
-          </p:txBody>
-        </p:sp>
-        <p:sp>
-          <p:nvSpPr>
-            <p:cNvPr id="4" name="Rectangle 3"/>
-            <p:cNvSpPr/>
-            <p:nvPr/>
-          </p:nvSpPr>
-          <p:spPr>
-            <a:xfrm>
-              <a:off x="457200" y="1188720"/>
-              <a:ext cx="109728" cy="4389120"/>
-            </a:xfrm>
-            <a:prstGeom prst="rect">
-              <a:avLst/>
-            </a:prstGeom>
-            <a:solidFill>
-              <a:srgbClr val="EA580C"/>
-            </a:solidFill>
-            <a:ln>
-              <a:noFill/>
-            </a:ln>
-          </p:spPr>
-          <p:style>
-            <a:lnRef idx="1">
-              <a:schemeClr val="accent1"/>
-            </a:lnRef>
-            <a:fillRef idx="3">
-              <a:schemeClr val="accent1"/>
-            </a:fillRef>
-            <a:effectRef idx="2">
-              <a:schemeClr val="accent1"/>
-            </a:effectRef>
-            <a:fontRef idx="minor">
-              <a:schemeClr val="lt1"/>
-            </a:fontRef>
-          </p:style>
-          <p:txBody>
-            <a:bodyPr rtlCol="0" anchor="ctr"/>
-            <a:lstStyle/>
-            <a:p>
-              <a:pPr algn="ctr"/>
-            </a:p>
-          </p:txBody>
-        </p:sp>
-      </p:grpSp>
-      <p:sp>
-        <p:nvSpPr>
-          <p:cNvPr id="5" name="TextBox 4"/>
-          <p:cNvSpPr txBox="1"/>
-          <p:nvPr/>
-        </p:nvSpPr>
-        <p:spPr>
-          <a:xfrm>
-            <a:off x="914400" y="1371600"/>
-            <a:ext cx="10515600" cy="4023360"/>
-          </a:xfrm>
-          <a:prstGeom prst="rect">
-            <a:avLst/>
-          </a:prstGeom>
-          <a:noFill/>
-        </p:spPr>
-        <p:txBody>
-          <a:bodyPr wrap="square" tIns="91440" bIns="91440">
-            <a:spAutoFit/>
-          </a:bodyPr>
-          <a:lstStyle/>
-          <a:p>
-            <a:pPr algn="l">
-              <a:spcAft>
-                <a:spcPts val="1200"/>
-              </a:spcAft>
-            </a:pPr>
-            <a:r>
-              <a:rPr sz="2400">
-                <a:solidFill>
-                  <a:srgbClr val="EA580C"/>
-                </a:solidFill>
-                <a:latin typeface="Times New Roman"/>
-              </a:rPr>
-              <a:t>📝  Nhiệm vụ mở rộng (Homework)</a:t>
-            </a:r>
-          </a:p>
-          <a:p>
-            <a:pPr algn="l">
-              <a:lnSpc>
-                <a:spcPts val="2800"/>
-              </a:lnSpc>
-              <a:spcAft>
-                <a:spcPts val="800"/>
-              </a:spcAft>
-            </a:pPr>
-            <a:r>
-              <a:rPr sz="1400">
-                <a:solidFill>
-                  <a:srgbClr val="EA580C"/>
-                </a:solidFill>
-                <a:latin typeface="Times New Roman"/>
-              </a:rPr>
-              <a:t>● </a:t>
-            </a:r>
-            <a:r>
-              <a:rPr sz="1800">
-                <a:solidFill>
-                  <a:srgbClr val="1E293B"/>
-                </a:solidFill>
-                <a:latin typeface="Times New Roman"/>
-              </a:rPr>
-              <a:t>Phác thảo ý tưởng 1 mô hình Robot em ước mơ chế tạo.</a:t>
-            </a:r>
-          </a:p>
-          <a:p>
-            <a:pPr algn="l">
-              <a:lnSpc>
-                <a:spcPts val="2800"/>
-              </a:lnSpc>
-              <a:spcAft>
-                <a:spcPts val="800"/>
-              </a:spcAft>
-            </a:pPr>
-            <a:r>
-              <a:rPr sz="1400">
-                <a:solidFill>
-                  <a:srgbClr val="EA580C"/>
-                </a:solidFill>
-                <a:latin typeface="Times New Roman"/>
-              </a:rPr>
-              <a:t>● </a:t>
-            </a:r>
-            <a:r>
-              <a:rPr sz="1800">
-                <a:solidFill>
-                  <a:srgbClr val="1E293B"/>
-                </a:solidFill>
-                <a:latin typeface="Times New Roman"/>
-              </a:rPr>
-              <a:t>Đặt tên và mô tả tính năng chính của Robot đó.</a:t>
-            </a:r>
-          </a:p>
-          <a:p>
-            <a:pPr algn="l">
-              <a:lnSpc>
-                <a:spcPts val="2800"/>
-              </a:lnSpc>
-              <a:spcAft>
-                <a:spcPts val="800"/>
-              </a:spcAft>
-            </a:pPr>
-            <a:r>
-              <a:rPr sz="1400">
-                <a:solidFill>
-                  <a:srgbClr val="EA580C"/>
-                </a:solidFill>
-                <a:latin typeface="Times New Roman"/>
-              </a:rPr>
-              <a:t>● </a:t>
-            </a:r>
-            <a:r>
-              <a:rPr sz="1800">
-                <a:solidFill>
-                  <a:srgbClr val="1E293B"/>
-                </a:solidFill>
-                <a:latin typeface="Times New Roman"/>
-              </a:rPr>
-              <a:t>Cam kết thực hiện đúng nội quy bảo quản bộ Kit Robotics.</a:t>
-            </a:r>
-          </a:p>
-          <a:p>
-            <a:pPr algn="l">
-              <a:lnSpc>
-                <a:spcPts val="2800"/>
-              </a:lnSpc>
-              <a:spcAft>
-                <a:spcPts val="800"/>
-              </a:spcAft>
-            </a:pPr>
-            <a:r>
-              <a:rPr sz="1400">
-                <a:solidFill>
-                  <a:srgbClr val="EA580C"/>
-                </a:solidFill>
-                <a:latin typeface="Times New Roman"/>
-              </a:rPr>
-              <a:t>● </a:t>
-            </a:r>
-            <a:r>
-              <a:rPr sz="1800">
-                <a:solidFill>
-                  <a:srgbClr val="1E293B"/>
-                </a:solidFill>
-                <a:latin typeface="Times New Roman"/>
-              </a:rPr>
-              <a:t>Xem trước Bài 1 trong chương trình Robotics.</a:t>
-            </a:r>
-          </a:p>
-        </p:txBody>
-      </p:sp>
-    </p:spTree>
-  </p:cSld>
-  <p:clrMapOvr>
-    <a:masterClrMapping/>
-  </p:clrMapOvr>
-</p:sld>
-</file>
-
-<file path=ppt/slides/slide9.xml><?xml version="1.0" encoding="utf-8"?>
-<p:sld xmlns:a="http://schemas.openxmlformats.org/drawingml/2006/main" xmlns:p="http://schemas.openxmlformats.org/presentationml/2006/main" xmlns:r="http://schemas.openxmlformats.org/officeDocument/2006/relationships">
-  <p:cSld>
-    <p:bg>
-      <p:bgPr>
-        <a:solidFill>
-          <a:srgbClr val="E0F2FE"/>
-        </a:solidFill>
-        <a:effectLst/>
-      </p:bgPr>
-    </p:bg>
-    <p:spTree>
-      <p:nvGrpSpPr>
-        <p:cNvPr id="1" name=""/>
-        <p:cNvGrpSpPr/>
-        <p:nvPr/>
-      </p:nvGrpSpPr>
-      <p:grpSpPr/>
-      <p:sp>
-        <p:nvSpPr>
-          <p:cNvPr id="2" name="Rectangle 1"/>
-          <p:cNvSpPr/>
-          <p:nvPr/>
-        </p:nvSpPr>
-        <p:spPr>
-          <a:xfrm>
-            <a:off x="0" y="1051560"/>
-            <a:ext cx="12188952" cy="4709160"/>
-          </a:xfrm>
-          <a:prstGeom prst="rect">
-            <a:avLst/>
-          </a:prstGeom>
-          <a:solidFill>
-            <a:srgbClr val="0C4A6E"/>
-          </a:solidFill>
-          <a:ln>
-            <a:noFill/>
-          </a:ln>
-        </p:spPr>
-        <p:style>
-          <a:lnRef idx="1">
-            <a:schemeClr val="accent1"/>
-          </a:lnRef>
-          <a:fillRef idx="3">
-            <a:schemeClr val="accent1"/>
-          </a:fillRef>
-          <a:effectRef idx="2">
-            <a:schemeClr val="accent1"/>
-          </a:effectRef>
-          <a:fontRef idx="minor">
-            <a:schemeClr val="lt1"/>
-          </a:fontRef>
-        </p:style>
-        <p:txBody>
-          <a:bodyPr rtlCol="0" anchor="ctr"/>
-          <a:lstStyle/>
-          <a:p>
-            <a:pPr algn="ctr"/>
-          </a:p>
-        </p:txBody>
-      </p:sp>
-      <p:grpSp>
-        <p:nvGrpSpPr>
-          <p:cNvPr id="3" name="Group 2"/>
-          <p:cNvGrpSpPr/>
-          <p:nvPr/>
-        </p:nvGrpSpPr>
-        <p:grpSpPr>
-          <a:xfrm>
-            <a:off x="1097280" y="1371600"/>
-            <a:ext cx="9966960" cy="4114800"/>
-            <a:chOff x="1097280" y="1371600"/>
-            <a:chExt cx="9966960" cy="4114800"/>
-          </a:xfrm>
-        </p:grpSpPr>
-        <p:sp>
-          <p:nvSpPr>
-            <p:cNvPr id="4" name="Rounded Rectangle 3"/>
-            <p:cNvSpPr/>
-            <p:nvPr/>
-          </p:nvSpPr>
-          <p:spPr>
-            <a:xfrm>
-              <a:off x="1097280" y="1371600"/>
-              <a:ext cx="9966960" cy="4114800"/>
-            </a:xfrm>
-            <a:prstGeom prst="roundRect">
-              <a:avLst/>
-            </a:prstGeom>
-            <a:solidFill>
-              <a:srgbClr val="FFFFFF"/>
-            </a:solidFill>
-            <a:ln>
-              <a:noFill/>
-            </a:ln>
-          </p:spPr>
-          <p:style>
-            <a:lnRef idx="1">
-              <a:schemeClr val="accent1"/>
-            </a:lnRef>
-            <a:fillRef idx="3">
-              <a:schemeClr val="accent1"/>
-            </a:fillRef>
-            <a:effectRef idx="2">
-              <a:schemeClr val="accent1"/>
-            </a:effectRef>
-            <a:fontRef idx="minor">
-              <a:schemeClr val="lt1"/>
-            </a:fontRef>
-          </p:style>
-          <p:txBody>
-            <a:bodyPr rtlCol="0" anchor="ctr"/>
-            <a:lstStyle/>
-            <a:p>
-              <a:pPr algn="ctr"/>
-            </a:p>
-          </p:txBody>
-        </p:sp>
-        <p:sp>
-          <p:nvSpPr>
-            <p:cNvPr id="5" name="Rectangle 4"/>
-            <p:cNvSpPr/>
-            <p:nvPr/>
-          </p:nvSpPr>
-          <p:spPr>
-            <a:xfrm>
-              <a:off x="1097280" y="1371600"/>
-              <a:ext cx="164592" cy="4114800"/>
-            </a:xfrm>
-            <a:prstGeom prst="rect">
-              <a:avLst/>
-            </a:prstGeom>
-            <a:solidFill>
-              <a:srgbClr val="EA580C"/>
-            </a:solidFill>
-            <a:ln>
-              <a:noFill/>
-            </a:ln>
-          </p:spPr>
-          <p:style>
-            <a:lnRef idx="1">
-              <a:schemeClr val="accent1"/>
-            </a:lnRef>
-            <a:fillRef idx="3">
-              <a:schemeClr val="accent1"/>
-            </a:fillRef>
-            <a:effectRef idx="2">
-              <a:schemeClr val="accent1"/>
-            </a:effectRef>
-            <a:fontRef idx="minor">
-              <a:schemeClr val="lt1"/>
-            </a:fontRef>
-          </p:style>
-          <p:txBody>
-            <a:bodyPr rtlCol="0" anchor="ctr"/>
-            <a:lstStyle/>
-            <a:p>
-              <a:pPr algn="ctr"/>
-            </a:p>
-          </p:txBody>
-        </p:sp>
-      </p:grpSp>
-      <p:sp>
-        <p:nvSpPr>
-          <p:cNvPr id="6" name="TextBox 5"/>
-          <p:cNvSpPr txBox="1"/>
-          <p:nvPr/>
-        </p:nvSpPr>
-        <p:spPr>
-          <a:xfrm>
-            <a:off x="1554480" y="1554480"/>
-            <a:ext cx="9144000" cy="3657600"/>
-          </a:xfrm>
-          <a:prstGeom prst="rect">
-            <a:avLst/>
-          </a:prstGeom>
-          <a:noFill/>
-        </p:spPr>
-        <p:txBody>
-          <a:bodyPr wrap="square" tIns="91440" bIns="91440">
-            <a:spAutoFit/>
-          </a:bodyPr>
-          <a:lstStyle/>
-          <a:p>
-            <a:pPr algn="l">
-              <a:spcAft>
-                <a:spcPts val="1200"/>
-              </a:spcAft>
-            </a:pPr>
-            <a:r>
-              <a:rPr sz="2400">
-                <a:solidFill>
-                  <a:srgbClr val="0C4A6E"/>
-                </a:solidFill>
-                <a:latin typeface="Times New Roman"/>
-              </a:rPr>
-              <a:t>📌  Ghi nhớ — Robotics Lớp 1</a:t>
-            </a:r>
-          </a:p>
-          <a:p>
-            <a:pPr algn="l">
-              <a:lnSpc>
-                <a:spcPts val="2800"/>
-              </a:lnSpc>
-              <a:spcAft>
-                <a:spcPts val="800"/>
-              </a:spcAft>
-            </a:pPr>
-            <a:r>
-              <a:rPr sz="1400">
-                <a:solidFill>
-                  <a:srgbClr val="EA580C"/>
-                </a:solidFill>
-                <a:latin typeface="Times New Roman"/>
-              </a:rPr>
-              <a:t>● </a:t>
-            </a:r>
-            <a:r>
-              <a:rPr sz="1800">
-                <a:solidFill>
-                  <a:srgbClr val="1E293B"/>
-                </a:solidFill>
-                <a:latin typeface="Times New Roman"/>
-              </a:rPr>
-              <a:t>Robotics giúp em tự tay biến ý tưởng thành hiện thực.</a:t>
-            </a:r>
-          </a:p>
-          <a:p>
-            <a:pPr algn="l">
-              <a:lnSpc>
-                <a:spcPts val="2800"/>
-              </a:lnSpc>
-              <a:spcAft>
-                <a:spcPts val="800"/>
-              </a:spcAft>
-            </a:pPr>
-            <a:r>
-              <a:rPr sz="1400">
-                <a:solidFill>
-                  <a:srgbClr val="EA580C"/>
-                </a:solidFill>
-                <a:latin typeface="Times New Roman"/>
-              </a:rPr>
-              <a:t>● </a:t>
-            </a:r>
-            <a:r>
-              <a:rPr sz="1800">
-                <a:solidFill>
-                  <a:srgbClr val="1E293B"/>
-                </a:solidFill>
-                <a:latin typeface="Times New Roman"/>
-              </a:rPr>
-              <a:t>Cẩn thận, tỉ mỉ &amp; tuân thủ an toàn thiết bị.</a:t>
-            </a:r>
-          </a:p>
-          <a:p>
-            <a:pPr algn="l">
-              <a:lnSpc>
-                <a:spcPts val="2800"/>
-              </a:lnSpc>
-              <a:spcAft>
-                <a:spcPts val="800"/>
-              </a:spcAft>
-            </a:pPr>
-            <a:r>
-              <a:rPr sz="1400">
-                <a:solidFill>
-                  <a:srgbClr val="EA580C"/>
-                </a:solidFill>
-                <a:latin typeface="Times New Roman"/>
-              </a:rPr>
-              <a:t>● </a:t>
-            </a:r>
-            <a:r>
-              <a:rPr sz="1800">
-                <a:solidFill>
-                  <a:srgbClr val="1E293B"/>
-                </a:solidFill>
-                <a:latin typeface="Times New Roman"/>
-              </a:rPr>
-              <a:t>Đam mê sáng tạo — Chinh phục công nghệ!</a:t>
-            </a:r>
-          </a:p>
-          <a:p>
-            <a:pPr algn="ctr">
-              <a:spcBef>
-                <a:spcPts val="2000"/>
-              </a:spcBef>
-            </a:pPr>
-            <a:r>
-              <a:rPr sz="2200">
-                <a:solidFill>
-                  <a:srgbClr val="0284C7"/>
-                </a:solidFill>
-                <a:latin typeface="Times New Roman"/>
-              </a:rPr>
-              <a:t>Chúc các em một năm học Robotics bùng nổ! 🚀🤖</a:t>
             </a:r>
           </a:p>
         </p:txBody>

</xml_diff>